<commit_message>
Update PPT layout per request
</commit_message>
<xml_diff>
--- a/吴锴烨_champion.pptx
+++ b/吴锴烨_champion.pptx
@@ -3126,12 +3126,10 @@
           <a:prstGeom prst="rect">
             <a:avLst/>
           </a:prstGeom>
-          <a:solidFill>
-            <a:srgbClr val="EFF1F1"/>
-          </a:solidFill>
           <a:ln>
             <a:noFill/>
           </a:ln>
+          <a:noFill/>
         </p:spPr>
         <p:style>
           <a:lnRef idx="1">
@@ -3469,8 +3467,8 @@
         </p:blipFill>
         <p:spPr>
           <a:xfrm>
-            <a:off x="4775050" y="2098476"/>
-            <a:ext cx="2534793" cy="4170164"/>
+            <a:off x="4752190" y="2075616"/>
+            <a:ext cx="2580513" cy="4215884"/>
           </a:xfrm>
           <a:prstGeom prst="rect">
             <a:avLst/>
@@ -3652,8 +3650,8 @@
         </p:nvSpPr>
         <p:spPr>
           <a:xfrm>
-            <a:off x="8486715" y="3289339"/>
-            <a:ext cx="1912564" cy="2739628"/>
+            <a:off x="8266675" y="3140000"/>
+            <a:ext cx="2352644" cy="2990000"/>
           </a:xfrm>
           <a:prstGeom prst="rect">
             <a:avLst/>
@@ -3661,7 +3659,7 @@
           <a:noFill/>
         </p:spPr>
         <p:txBody>
-          <a:bodyPr wrap="square" lIns="45720" rIns="45720" tIns="0" bIns="0" anchor="ctr">
+          <a:bodyPr wrap="square" lIns="68580" rIns="68580" tIns="45720" bIns="45720" anchor="ctr">
             <a:spAutoFit/>
           </a:bodyPr>
           <a:lstStyle/>
@@ -3671,7 +3669,7 @@
                 <a:spcPct val="105000"/>
               </a:lnSpc>
               <a:spcAft>
-                <a:spcPts val="1300"/>
+                <a:spcPts val="1100"/>
               </a:spcAft>
             </a:pPr>
             <a:r>
@@ -3690,7 +3688,7 @@
                 <a:spcPct val="105000"/>
               </a:lnSpc>
               <a:spcAft>
-                <a:spcPts val="1300"/>
+                <a:spcPts val="1100"/>
               </a:spcAft>
             </a:pPr>
             <a:r>
@@ -3709,7 +3707,7 @@
                 <a:spcPct val="105000"/>
               </a:lnSpc>
               <a:spcAft>
-                <a:spcPts val="1300"/>
+                <a:spcPts val="1100"/>
               </a:spcAft>
             </a:pPr>
             <a:r>
@@ -3728,11 +3726,11 @@
                 <a:spcPct val="105000"/>
               </a:lnSpc>
               <a:spcAft>
-                <a:spcPts val="1300"/>
+                <a:spcPts val="1100"/>
               </a:spcAft>
             </a:pPr>
             <a:r>
-              <a:rPr sz="2100" b="1">
+              <a:rPr sz="2200" b="1">
                 <a:solidFill>
                   <a:srgbClr val="F4C979"/>
                 </a:solidFill>

</xml_diff>